<commit_message>
Refactor: trim dead code bloat, remove unused imports, and synchronize presentation artifacts
</commit_message>
<xml_diff>
--- a/Explainable_House_Price_Prediction_Presentation.pptx
+++ b/Explainable_House_Price_Prediction_Presentation.pptx
@@ -9286,7 +9286,7 @@
                   <a:srgbClr val="1E293B"/>
                 </a:solidFill>
               </a:rPr>
-              <a:t>$15,321 average error (&lt;pptx.text.text._Run object at 0x000001C71D10A350&gt;)</a:t>
+              <a:t>$15,321 average error (&lt;pptx.text.text._Run object at 0x00000170A5462510&gt;)</a:t>
             </a:r>
           </a:p>
           <a:p>
@@ -9312,7 +9312,7 @@
                   <a:srgbClr val="1E293B"/>
                 </a:solidFill>
               </a:rPr>
-              <a:t>$15,858 average error (&lt;pptx.text.text._Run object at 0x000001C71BE8B950&gt;)</a:t>
+              <a:t>$15,858 average error (&lt;pptx.text.text._Run object at 0x00000170A528F950&gt;)</a:t>
             </a:r>
           </a:p>
           <a:p>
@@ -9338,7 +9338,7 @@
                   <a:srgbClr val="1E293B"/>
                 </a:solidFill>
               </a:rPr>
-              <a:t>$16,749 average error (&lt;pptx.text.text._Run object at 0x000001C71D16C5D0&gt;)</a:t>
+              <a:t>$16,749 average error (&lt;pptx.text.text._Run object at 0x00000170A54C0680&gt;)</a:t>
             </a:r>
           </a:p>
           <a:p>
@@ -9364,7 +9364,7 @@
                   <a:srgbClr val="1E293B"/>
                 </a:solidFill>
               </a:rPr>
-              <a:t>$21,093 average error (&lt;pptx.text.text._Run object at 0x000001C71D1B6030&gt;)</a:t>
+              <a:t>$21,093 average error (&lt;pptx.text.text._Run object at 0x00000170A5512530&gt;)</a:t>
             </a:r>
           </a:p>
           <a:p>
@@ -9390,7 +9390,7 @@
                   <a:srgbClr val="1E293B"/>
                 </a:solidFill>
               </a:rPr>
-              <a:t>$27,458 average error (&lt;pptx.text.text._Run object at 0x000001C71D05B890&gt;)</a:t>
+              <a:t>$27,458 average error (&lt;pptx.text.text._Run object at 0x00000170A53AF920&gt;)</a:t>
             </a:r>
           </a:p>
           <a:p>
@@ -9416,7 +9416,7 @@
                   <a:srgbClr val="1E293B"/>
                 </a:solidFill>
               </a:rPr>
-              <a:t>$58,761 average error (&lt;pptx.text.text._Run object at 0x000001C71D1B0BD0&gt;)</a:t>
+              <a:t>$58,761 average error (&lt;pptx.text.text._Run object at 0x00000170A54F1350&gt;)</a:t>
             </a:r>
           </a:p>
           <a:p>

</xml_diff>